<commit_message>
DEX-Foliensatz: KPI-Karten ausbalanciert, Budgetzahlen ergänzt
- Folie 1 (KPIs): Texte auf gleiche Länge gebracht und Kartenhöhe enger
  gesetzt, damit die Karten-Böden nicht mehr ungleich leer wirken.
- Folie 3 (Plan): konkrete Budgetzahlen auf der Budget-Karte
  (~5.000 EUR FY25/26, ~10.000 EUR ab FY26/27, Code GASR8771).
- Titelfolie + grüner Divider vorangestellt (5 Folien gesamt).

Co-Authored-By: Claude Opus 4.8 <noreply@anthropic.com>
Claude-Session: https://claude.ai/code/session_01MmMSE8Hbzv2C1tR9TCLFkk
</commit_message>
<xml_diff>
--- a/20260629_DEX_Update.pptx
+++ b/20260629_DEX_Update.pptx
@@ -33199,7 +33199,7 @@
         <p:spPr>
           <a:xfrm>
             <a:off x="502920" y="1847088"/>
-            <a:ext cx="2576322" cy="4069080"/>
+            <a:ext cx="2576322" cy="3657600"/>
           </a:xfrm>
           <a:prstGeom prst="roundRect">
             <a:avLst>
@@ -33294,7 +33294,7 @@
                 </a:solidFill>
                 <a:latin typeface="Aptos"/>
               </a:rPr>
-              <a:t>Bewusst gegen die Entwicklung mit Indien entschieden (Komplexität, Skillset, Budget, Zeit). KI-gestützt eigenständig auf eine neue Architektur migriert – live &amp; produktiv.</a:t>
+              <a:t>Bewusst gegen Indien entschieden – KI-gestützt eigenständig neu aufgebaut, live &amp; produktiv.</a:t>
             </a:r>
           </a:p>
         </p:txBody>
@@ -33376,7 +33376,7 @@
         <p:spPr>
           <a:xfrm>
             <a:off x="3371850" y="1847088"/>
-            <a:ext cx="2576322" cy="4069080"/>
+            <a:ext cx="2576322" cy="3657600"/>
           </a:xfrm>
           <a:prstGeom prst="roundRect">
             <a:avLst>
@@ -33471,7 +33471,7 @@
                 </a:solidFill>
                 <a:latin typeface="Aptos"/>
               </a:rPr>
-              <a:t>Seit dem Wechsel 29 Events vollständig über DEX abgewickelt – Tendenz weiter steigend.</a:t>
+              <a:t>29 Events vollständig über DEX abgewickelt – von kleinen Runden bis Großevents, Tendenz steigend.</a:t>
             </a:r>
           </a:p>
         </p:txBody>
@@ -33553,7 +33553,7 @@
         <p:spPr>
           <a:xfrm>
             <a:off x="6240779" y="1847088"/>
-            <a:ext cx="2576322" cy="4069080"/>
+            <a:ext cx="2576322" cy="3657600"/>
           </a:xfrm>
           <a:prstGeom prst="roundRect">
             <a:avLst>
@@ -33648,7 +33648,7 @@
                 </a:solidFill>
                 <a:latin typeface="Aptos"/>
               </a:rPr>
-              <a:t>Rund 7.000 Anmeldungen gesteuert – inkl. vollautomatischer Mail- &amp; Outlook-Anbindung, die den Assistenzen viel Zeit spart.</a:t>
+              <a:t>Rund 7.000 Anmeldungen gesteuert – automatische Mail- &amp; Outlook-Anbindung spart den Assistenzen viel Zeit.</a:t>
             </a:r>
           </a:p>
         </p:txBody>
@@ -33730,7 +33730,7 @@
         <p:spPr>
           <a:xfrm>
             <a:off x="9109710" y="1847088"/>
-            <a:ext cx="2576322" cy="4069080"/>
+            <a:ext cx="2576322" cy="3657600"/>
           </a:xfrm>
           <a:prstGeom prst="roundRect">
             <a:avLst>
@@ -33825,7 +33825,7 @@
                 </a:solidFill>
                 <a:latin typeface="Aptos"/>
               </a:rPr>
-              <a:t>Event-Erstellung läuft eigenständig durch die Assistenzen – ohne operative Einbindung von Nils &amp; Eike. 72 Std. Eigenleistung gebucht.</a:t>
+              <a:t>Event-Erstellung läuft eigenständig durch die Assistenzen – kaum noch operative Einbindung. 72 Std. Eigenleistung gebucht.</a:t>
             </a:r>
           </a:p>
         </p:txBody>

</xml_diff>